<commit_message>
data-eng 4-4 덱 5(실습점검 신설) — 2026-10-15 실측
</commit_message>
<xml_diff>
--- a/data-eng/decks/w4d4s1.pptx
+++ b/data-eng/decks/w4d4s1.pptx
@@ -3100,7 +3100,7 @@
       <p:grpSpPr/>
       <p:sp>
         <p:nvSpPr>
-          <p:cNvPr id="2" name="Oval 1"/>
+          <p:cNvPr id="2" name="deckgen:decor"/>
           <p:cNvSpPr/>
           <p:nvPr/>
         </p:nvSpPr>
@@ -3130,7 +3130,7 @@
       </p:sp>
       <p:sp>
         <p:nvSpPr>
-          <p:cNvPr id="3" name="Oval 2"/>
+          <p:cNvPr id="3" name="deckgen:decor"/>
           <p:cNvSpPr/>
           <p:nvPr/>
         </p:nvSpPr>
@@ -3160,7 +3160,7 @@
       </p:sp>
       <p:sp>
         <p:nvSpPr>
-          <p:cNvPr id="4" name="Oval 3"/>
+          <p:cNvPr id="4" name="deckgen:decor"/>
           <p:cNvSpPr/>
           <p:nvPr/>
         </p:nvSpPr>
@@ -3190,7 +3190,7 @@
       </p:sp>
       <p:sp>
         <p:nvSpPr>
-          <p:cNvPr id="5" name="Rectangle 4"/>
+          <p:cNvPr id="5" name="deckgen:decor"/>
           <p:cNvSpPr/>
           <p:nvPr/>
         </p:nvSpPr>
@@ -3220,7 +3220,7 @@
       </p:sp>
       <p:sp>
         <p:nvSpPr>
-          <p:cNvPr id="6" name="Oval 5"/>
+          <p:cNvPr id="6" name="deckgen:decor"/>
           <p:cNvSpPr/>
           <p:nvPr/>
         </p:nvSpPr>
@@ -3250,7 +3250,7 @@
       </p:sp>
       <p:sp>
         <p:nvSpPr>
-          <p:cNvPr id="7" name="Oval 6"/>
+          <p:cNvPr id="7" name="deckgen:decor"/>
           <p:cNvSpPr/>
           <p:nvPr/>
         </p:nvSpPr>
@@ -3280,7 +3280,7 @@
       </p:sp>
       <p:sp>
         <p:nvSpPr>
-          <p:cNvPr id="8" name="Oval 7"/>
+          <p:cNvPr id="8" name="deckgen:decor"/>
           <p:cNvSpPr/>
           <p:nvPr/>
         </p:nvSpPr>
@@ -3310,7 +3310,7 @@
       </p:sp>
       <p:sp>
         <p:nvSpPr>
-          <p:cNvPr id="9" name="Oval 8"/>
+          <p:cNvPr id="9" name="deckgen:decor"/>
           <p:cNvSpPr/>
           <p:nvPr/>
         </p:nvSpPr>
@@ -3340,7 +3340,7 @@
       </p:sp>
       <p:sp>
         <p:nvSpPr>
-          <p:cNvPr id="10" name="Rectangle 9"/>
+          <p:cNvPr id="10" name="deckgen:decor"/>
           <p:cNvSpPr/>
           <p:nvPr/>
         </p:nvSpPr>
@@ -3600,7 +3600,7 @@
       <p:grpSpPr/>
       <p:sp>
         <p:nvSpPr>
-          <p:cNvPr id="2" name="Oval 1"/>
+          <p:cNvPr id="2" name="deckgen:decor"/>
           <p:cNvSpPr/>
           <p:nvPr/>
         </p:nvSpPr>
@@ -3630,7 +3630,7 @@
       </p:sp>
       <p:sp>
         <p:nvSpPr>
-          <p:cNvPr id="3" name="Oval 2"/>
+          <p:cNvPr id="3" name="deckgen:decor"/>
           <p:cNvSpPr/>
           <p:nvPr/>
         </p:nvSpPr>
@@ -3660,7 +3660,7 @@
       </p:sp>
       <p:sp>
         <p:nvSpPr>
-          <p:cNvPr id="4" name="Oval 3"/>
+          <p:cNvPr id="4" name="deckgen:decor"/>
           <p:cNvSpPr/>
           <p:nvPr/>
         </p:nvSpPr>
@@ -4662,7 +4662,7 @@
       <p:grpSpPr/>
       <p:sp>
         <p:nvSpPr>
-          <p:cNvPr id="2" name="Oval 1"/>
+          <p:cNvPr id="2" name="deckgen:decor"/>
           <p:cNvSpPr/>
           <p:nvPr/>
         </p:nvSpPr>
@@ -4692,7 +4692,7 @@
       </p:sp>
       <p:sp>
         <p:nvSpPr>
-          <p:cNvPr id="3" name="Oval 2"/>
+          <p:cNvPr id="3" name="deckgen:decor"/>
           <p:cNvSpPr/>
           <p:nvPr/>
         </p:nvSpPr>
@@ -5100,7 +5100,7 @@
                 <a:ea typeface="Pretendard"/>
                 <a:cs typeface="Pretendard"/>
               </a:rPr>
-              <a:t>up -d trino 뒤 SERVER STARTED 대기</a:t>
+              <a:t>compose 교체 · up -d 뒤 「준비 완료」 대기</a:t>
             </a:r>
           </a:p>
         </p:txBody>
@@ -5469,7 +5469,7 @@
       <p:grpSpPr/>
       <p:sp>
         <p:nvSpPr>
-          <p:cNvPr id="2" name="Oval 1"/>
+          <p:cNvPr id="2" name="deckgen:decor"/>
           <p:cNvSpPr/>
           <p:nvPr/>
         </p:nvSpPr>
@@ -5499,7 +5499,7 @@
       </p:sp>
       <p:sp>
         <p:nvSpPr>
-          <p:cNvPr id="3" name="Oval 2"/>
+          <p:cNvPr id="3" name="deckgen:decor"/>
           <p:cNvSpPr/>
           <p:nvPr/>
         </p:nvSpPr>
@@ -5529,7 +5529,7 @@
       </p:sp>
       <p:sp>
         <p:nvSpPr>
-          <p:cNvPr id="4" name="Oval 3"/>
+          <p:cNvPr id="4" name="deckgen:decor"/>
           <p:cNvSpPr/>
           <p:nvPr/>
         </p:nvSpPr>
@@ -6460,7 +6460,7 @@
       <p:grpSpPr/>
       <p:sp>
         <p:nvSpPr>
-          <p:cNvPr id="2" name="Oval 1"/>
+          <p:cNvPr id="2" name="deckgen:decor"/>
           <p:cNvSpPr/>
           <p:nvPr/>
         </p:nvSpPr>
@@ -6490,7 +6490,7 @@
       </p:sp>
       <p:sp>
         <p:nvSpPr>
-          <p:cNvPr id="3" name="Oval 2"/>
+          <p:cNvPr id="3" name="deckgen:decor"/>
           <p:cNvSpPr/>
           <p:nvPr/>
         </p:nvSpPr>
@@ -6520,7 +6520,7 @@
       </p:sp>
       <p:sp>
         <p:nvSpPr>
-          <p:cNvPr id="4" name="Oval 3"/>
+          <p:cNvPr id="4" name="deckgen:decor"/>
           <p:cNvSpPr/>
           <p:nvPr/>
         </p:nvSpPr>
@@ -8212,7 +8212,7 @@
       <p:grpSpPr/>
       <p:sp>
         <p:nvSpPr>
-          <p:cNvPr id="2" name="Oval 1"/>
+          <p:cNvPr id="2" name="deckgen:decor"/>
           <p:cNvSpPr/>
           <p:nvPr/>
         </p:nvSpPr>
@@ -8242,7 +8242,7 @@
       </p:sp>
       <p:sp>
         <p:nvSpPr>
-          <p:cNvPr id="3" name="Oval 2"/>
+          <p:cNvPr id="3" name="deckgen:decor"/>
           <p:cNvSpPr/>
           <p:nvPr/>
         </p:nvSpPr>
@@ -8272,7 +8272,7 @@
       </p:sp>
       <p:sp>
         <p:nvSpPr>
-          <p:cNvPr id="4" name="Oval 3"/>
+          <p:cNvPr id="4" name="deckgen:decor"/>
           <p:cNvSpPr/>
           <p:nvPr/>
         </p:nvSpPr>
@@ -9332,7 +9332,7 @@
       <p:grpSpPr/>
       <p:sp>
         <p:nvSpPr>
-          <p:cNvPr id="2" name="Oval 1"/>
+          <p:cNvPr id="2" name="deckgen:decor"/>
           <p:cNvSpPr/>
           <p:nvPr/>
         </p:nvSpPr>
@@ -9362,7 +9362,7 @@
       </p:sp>
       <p:sp>
         <p:nvSpPr>
-          <p:cNvPr id="3" name="Oval 2"/>
+          <p:cNvPr id="3" name="deckgen:decor"/>
           <p:cNvSpPr/>
           <p:nvPr/>
         </p:nvSpPr>
@@ -9392,7 +9392,7 @@
       </p:sp>
       <p:sp>
         <p:nvSpPr>
-          <p:cNvPr id="4" name="Oval 3"/>
+          <p:cNvPr id="4" name="deckgen:decor"/>
           <p:cNvSpPr/>
           <p:nvPr/>
         </p:nvSpPr>
@@ -11043,7 +11043,7 @@
       <p:grpSpPr/>
       <p:sp>
         <p:nvSpPr>
-          <p:cNvPr id="2" name="Oval 1"/>
+          <p:cNvPr id="2" name="deckgen:decor"/>
           <p:cNvSpPr/>
           <p:nvPr/>
         </p:nvSpPr>
@@ -11073,7 +11073,7 @@
       </p:sp>
       <p:sp>
         <p:nvSpPr>
-          <p:cNvPr id="3" name="Oval 2"/>
+          <p:cNvPr id="3" name="deckgen:decor"/>
           <p:cNvSpPr/>
           <p:nvPr/>
         </p:nvSpPr>
@@ -11103,7 +11103,7 @@
       </p:sp>
       <p:sp>
         <p:nvSpPr>
-          <p:cNvPr id="4" name="Oval 3"/>
+          <p:cNvPr id="4" name="deckgen:decor"/>
           <p:cNvSpPr/>
           <p:nvPr/>
         </p:nvSpPr>
@@ -12070,7 +12070,7 @@
       <p:grpSpPr/>
       <p:sp>
         <p:nvSpPr>
-          <p:cNvPr id="2" name="Oval 1"/>
+          <p:cNvPr id="2" name="deckgen:decor"/>
           <p:cNvSpPr/>
           <p:nvPr/>
         </p:nvSpPr>
@@ -12100,7 +12100,7 @@
       </p:sp>
       <p:sp>
         <p:nvSpPr>
-          <p:cNvPr id="3" name="Oval 2"/>
+          <p:cNvPr id="3" name="deckgen:decor"/>
           <p:cNvSpPr/>
           <p:nvPr/>
         </p:nvSpPr>
@@ -12130,7 +12130,7 @@
       </p:sp>
       <p:sp>
         <p:nvSpPr>
-          <p:cNvPr id="4" name="Oval 3"/>
+          <p:cNvPr id="4" name="deckgen:decor"/>
           <p:cNvSpPr/>
           <p:nvPr/>
         </p:nvSpPr>
@@ -13131,7 +13131,7 @@
       <p:grpSpPr/>
       <p:sp>
         <p:nvSpPr>
-          <p:cNvPr id="2" name="Oval 1"/>
+          <p:cNvPr id="2" name="deckgen:decor"/>
           <p:cNvSpPr/>
           <p:nvPr/>
         </p:nvSpPr>
@@ -13161,7 +13161,7 @@
       </p:sp>
       <p:sp>
         <p:nvSpPr>
-          <p:cNvPr id="3" name="Oval 2"/>
+          <p:cNvPr id="3" name="deckgen:decor"/>
           <p:cNvSpPr/>
           <p:nvPr/>
         </p:nvSpPr>
@@ -13191,7 +13191,7 @@
       </p:sp>
       <p:sp>
         <p:nvSpPr>
-          <p:cNvPr id="4" name="Oval 3"/>
+          <p:cNvPr id="4" name="deckgen:decor"/>
           <p:cNvSpPr/>
           <p:nvPr/>
         </p:nvSpPr>
@@ -14149,7 +14149,7 @@
                 <a:ea typeface="Pretendard"/>
                 <a:cs typeface="Pretendard"/>
               </a:rPr>
-              <a:t>두 주소의 역할</a:t>
+              <a:t>주석은 따로 한 줄</a:t>
             </a:r>
           </a:p>
         </p:txBody>
@@ -14190,7 +14190,7 @@
                 <a:ea typeface="Pretendard"/>
                 <a:cs typeface="Pretendard"/>
               </a:rPr>
-              <a:t>(1) 위치 묻기</a:t>
+              <a:t>줄 끝 # 은</a:t>
             </a:r>
           </a:p>
           <a:p>
@@ -14208,7 +14208,7 @@
                 <a:ea typeface="Pretendard"/>
                 <a:cs typeface="Pretendard"/>
               </a:rPr>
-              <a:t>(2) 직접 읽기</a:t>
+              <a:t>값으로 읽힌다</a:t>
             </a:r>
           </a:p>
         </p:txBody>
@@ -14345,7 +14345,7 @@
       <p:grpSpPr/>
       <p:sp>
         <p:nvSpPr>
-          <p:cNvPr id="2" name="Oval 1"/>
+          <p:cNvPr id="2" name="deckgen:decor"/>
           <p:cNvSpPr/>
           <p:nvPr/>
         </p:nvSpPr>
@@ -14375,7 +14375,7 @@
       </p:sp>
       <p:sp>
         <p:nvSpPr>
-          <p:cNvPr id="3" name="Oval 2"/>
+          <p:cNvPr id="3" name="deckgen:decor"/>
           <p:cNvSpPr/>
           <p:nvPr/>
         </p:nvSpPr>
@@ -14405,7 +14405,7 @@
       </p:sp>
       <p:sp>
         <p:nvSpPr>
-          <p:cNvPr id="4" name="Oval 3"/>
+          <p:cNvPr id="4" name="deckgen:decor"/>
           <p:cNvSpPr/>
           <p:nvPr/>
         </p:nvSpPr>

</xml_diff>